<commit_message>
Airgap harmonics and some technical documents
airgap harmonics, first proposal are done. TI initialization and PCB documents are added.
</commit_message>
<xml_diff>
--- a/Airgap Harmonics/Past studies/SystemProposal-InputExcitation/CPS.pptx
+++ b/Airgap Harmonics/Past studies/SystemProposal-InputExcitation/CPS.pptx
@@ -225,7 +225,7 @@
           <a:p>
             <a:fld id="{28B67866-21BA-4CA6-832C-195CC621F675}" type="datetimeFigureOut">
               <a:rPr lang="en-US" smtClean="0"/>
-              <a:t>9/23/2022</a:t>
+              <a:t>11/11/2024</a:t>
             </a:fld>
             <a:endParaRPr lang="en-US"/>
           </a:p>
@@ -814,7 +814,7 @@
           <a:p>
             <a:fld id="{8DDB1700-4475-4CBC-B86D-A53CA45E6D33}" type="datetimeFigureOut">
               <a:rPr lang="en-US" smtClean="0"/>
-              <a:t>9/23/2022</a:t>
+              <a:t>11/11/2024</a:t>
             </a:fld>
             <a:endParaRPr lang="en-US"/>
           </a:p>
@@ -1012,7 +1012,7 @@
           <a:p>
             <a:fld id="{8DDB1700-4475-4CBC-B86D-A53CA45E6D33}" type="datetimeFigureOut">
               <a:rPr lang="en-US" smtClean="0"/>
-              <a:t>9/23/2022</a:t>
+              <a:t>11/11/2024</a:t>
             </a:fld>
             <a:endParaRPr lang="en-US"/>
           </a:p>
@@ -1220,7 +1220,7 @@
           <a:p>
             <a:fld id="{8DDB1700-4475-4CBC-B86D-A53CA45E6D33}" type="datetimeFigureOut">
               <a:rPr lang="en-US" smtClean="0"/>
-              <a:t>9/23/2022</a:t>
+              <a:t>11/11/2024</a:t>
             </a:fld>
             <a:endParaRPr lang="en-US"/>
           </a:p>
@@ -1418,7 +1418,7 @@
           <a:p>
             <a:fld id="{8DDB1700-4475-4CBC-B86D-A53CA45E6D33}" type="datetimeFigureOut">
               <a:rPr lang="en-US" smtClean="0"/>
-              <a:t>9/23/2022</a:t>
+              <a:t>11/11/2024</a:t>
             </a:fld>
             <a:endParaRPr lang="en-US"/>
           </a:p>
@@ -1693,7 +1693,7 @@
           <a:p>
             <a:fld id="{8DDB1700-4475-4CBC-B86D-A53CA45E6D33}" type="datetimeFigureOut">
               <a:rPr lang="en-US" smtClean="0"/>
-              <a:t>9/23/2022</a:t>
+              <a:t>11/11/2024</a:t>
             </a:fld>
             <a:endParaRPr lang="en-US"/>
           </a:p>
@@ -1958,7 +1958,7 @@
           <a:p>
             <a:fld id="{8DDB1700-4475-4CBC-B86D-A53CA45E6D33}" type="datetimeFigureOut">
               <a:rPr lang="en-US" smtClean="0"/>
-              <a:t>9/23/2022</a:t>
+              <a:t>11/11/2024</a:t>
             </a:fld>
             <a:endParaRPr lang="en-US"/>
           </a:p>
@@ -2370,7 +2370,7 @@
           <a:p>
             <a:fld id="{8DDB1700-4475-4CBC-B86D-A53CA45E6D33}" type="datetimeFigureOut">
               <a:rPr lang="en-US" smtClean="0"/>
-              <a:t>9/23/2022</a:t>
+              <a:t>11/11/2024</a:t>
             </a:fld>
             <a:endParaRPr lang="en-US"/>
           </a:p>
@@ -2511,7 +2511,7 @@
           <a:p>
             <a:fld id="{8DDB1700-4475-4CBC-B86D-A53CA45E6D33}" type="datetimeFigureOut">
               <a:rPr lang="en-US" smtClean="0"/>
-              <a:t>9/23/2022</a:t>
+              <a:t>11/11/2024</a:t>
             </a:fld>
             <a:endParaRPr lang="en-US"/>
           </a:p>
@@ -2624,7 +2624,7 @@
           <a:p>
             <a:fld id="{8DDB1700-4475-4CBC-B86D-A53CA45E6D33}" type="datetimeFigureOut">
               <a:rPr lang="en-US" smtClean="0"/>
-              <a:t>9/23/2022</a:t>
+              <a:t>11/11/2024</a:t>
             </a:fld>
             <a:endParaRPr lang="en-US"/>
           </a:p>
@@ -2935,7 +2935,7 @@
           <a:p>
             <a:fld id="{8DDB1700-4475-4CBC-B86D-A53CA45E6D33}" type="datetimeFigureOut">
               <a:rPr lang="en-US" smtClean="0"/>
-              <a:t>9/23/2022</a:t>
+              <a:t>11/11/2024</a:t>
             </a:fld>
             <a:endParaRPr lang="en-US"/>
           </a:p>
@@ -3223,7 +3223,7 @@
           <a:p>
             <a:fld id="{8DDB1700-4475-4CBC-B86D-A53CA45E6D33}" type="datetimeFigureOut">
               <a:rPr lang="en-US" smtClean="0"/>
-              <a:t>9/23/2022</a:t>
+              <a:t>11/11/2024</a:t>
             </a:fld>
             <a:endParaRPr lang="en-US"/>
           </a:p>
@@ -3464,7 +3464,7 @@
           <a:p>
             <a:fld id="{8DDB1700-4475-4CBC-B86D-A53CA45E6D33}" type="datetimeFigureOut">
               <a:rPr lang="en-US" smtClean="0"/>
-              <a:t>9/23/2022</a:t>
+              <a:t>11/11/2024</a:t>
             </a:fld>
             <a:endParaRPr lang="en-US"/>
           </a:p>
@@ -7129,8 +7129,8 @@
           <a:chExt cx="0" cy="0"/>
         </a:xfrm>
       </p:grpSpPr>
-      <mc:AlternateContent xmlns:mc="http://schemas.openxmlformats.org/markup-compatibility/2006">
-        <mc:Choice xmlns:a14="http://schemas.microsoft.com/office/drawing/2010/main" Requires="a14">
+      <mc:AlternateContent xmlns:mc="http://schemas.openxmlformats.org/markup-compatibility/2006" xmlns:a14="http://schemas.microsoft.com/office/drawing/2010/main">
+        <mc:Choice Requires="a14">
           <p:sp>
             <p:nvSpPr>
               <p:cNvPr id="11" name="TextBox 10">
@@ -7267,7 +7267,7 @@
             </p:txBody>
           </p:sp>
         </mc:Choice>
-        <mc:Fallback>
+        <mc:Fallback xmlns="">
           <p:sp>
             <p:nvSpPr>
               <p:cNvPr id="11" name="TextBox 10">
@@ -7312,8 +7312,8 @@
           </p:sp>
         </mc:Fallback>
       </mc:AlternateContent>
-      <mc:AlternateContent xmlns:mc="http://schemas.openxmlformats.org/markup-compatibility/2006">
-        <mc:Choice xmlns:a14="http://schemas.microsoft.com/office/drawing/2010/main" Requires="a14">
+      <mc:AlternateContent xmlns:mc="http://schemas.openxmlformats.org/markup-compatibility/2006" xmlns:a14="http://schemas.microsoft.com/office/drawing/2010/main">
+        <mc:Choice Requires="a14">
           <p:sp>
             <p:nvSpPr>
               <p:cNvPr id="12" name="TextBox 11">
@@ -7450,7 +7450,7 @@
             </p:txBody>
           </p:sp>
         </mc:Choice>
-        <mc:Fallback>
+        <mc:Fallback xmlns="">
           <p:sp>
             <p:nvSpPr>
               <p:cNvPr id="12" name="TextBox 11">
@@ -7645,8 +7645,8 @@
           <a:chExt cx="0" cy="0"/>
         </a:xfrm>
       </p:grpSpPr>
-      <mc:AlternateContent xmlns:mc="http://schemas.openxmlformats.org/markup-compatibility/2006">
-        <mc:Choice xmlns:a14="http://schemas.microsoft.com/office/drawing/2010/main" Requires="a14">
+      <mc:AlternateContent xmlns:mc="http://schemas.openxmlformats.org/markup-compatibility/2006" xmlns:a14="http://schemas.microsoft.com/office/drawing/2010/main">
+        <mc:Choice Requires="a14">
           <p:sp>
             <p:nvSpPr>
               <p:cNvPr id="11" name="TextBox 10">
@@ -7783,7 +7783,7 @@
             </p:txBody>
           </p:sp>
         </mc:Choice>
-        <mc:Fallback>
+        <mc:Fallback xmlns="">
           <p:sp>
             <p:nvSpPr>
               <p:cNvPr id="11" name="TextBox 10">
@@ -7828,8 +7828,8 @@
           </p:sp>
         </mc:Fallback>
       </mc:AlternateContent>
-      <mc:AlternateContent xmlns:mc="http://schemas.openxmlformats.org/markup-compatibility/2006">
-        <mc:Choice xmlns:a14="http://schemas.microsoft.com/office/drawing/2010/main" Requires="a14">
+      <mc:AlternateContent xmlns:mc="http://schemas.openxmlformats.org/markup-compatibility/2006" xmlns:a14="http://schemas.microsoft.com/office/drawing/2010/main">
+        <mc:Choice Requires="a14">
           <p:sp>
             <p:nvSpPr>
               <p:cNvPr id="12" name="TextBox 11">
@@ -7966,7 +7966,7 @@
             </p:txBody>
           </p:sp>
         </mc:Choice>
-        <mc:Fallback>
+        <mc:Fallback xmlns="">
           <p:sp>
             <p:nvSpPr>
               <p:cNvPr id="12" name="TextBox 11">
@@ -8489,8 +8489,8 @@
           </a:p>
         </p:txBody>
       </p:sp>
-      <mc:AlternateContent xmlns:mc="http://schemas.openxmlformats.org/markup-compatibility/2006">
-        <mc:Choice xmlns:a14="http://schemas.microsoft.com/office/drawing/2010/main" Requires="a14">
+      <mc:AlternateContent xmlns:mc="http://schemas.openxmlformats.org/markup-compatibility/2006" xmlns:a14="http://schemas.microsoft.com/office/drawing/2010/main">
+        <mc:Choice Requires="a14">
           <p:sp>
             <p:nvSpPr>
               <p:cNvPr id="10" name="TextBox 9">
@@ -8562,7 +8562,7 @@
             </p:txBody>
           </p:sp>
         </mc:Choice>
-        <mc:Fallback>
+        <mc:Fallback xmlns="">
           <p:sp>
             <p:nvSpPr>
               <p:cNvPr id="10" name="TextBox 9">
@@ -8607,8 +8607,8 @@
           </p:sp>
         </mc:Fallback>
       </mc:AlternateContent>
-      <mc:AlternateContent xmlns:mc="http://schemas.openxmlformats.org/markup-compatibility/2006">
-        <mc:Choice xmlns:a14="http://schemas.microsoft.com/office/drawing/2010/main" Requires="a14">
+      <mc:AlternateContent xmlns:mc="http://schemas.openxmlformats.org/markup-compatibility/2006" xmlns:a14="http://schemas.microsoft.com/office/drawing/2010/main">
+        <mc:Choice Requires="a14">
           <p:sp>
             <p:nvSpPr>
               <p:cNvPr id="11" name="TextBox 10">
@@ -8680,7 +8680,7 @@
             </p:txBody>
           </p:sp>
         </mc:Choice>
-        <mc:Fallback>
+        <mc:Fallback xmlns="">
           <p:sp>
             <p:nvSpPr>
               <p:cNvPr id="11" name="TextBox 10">
@@ -8933,8 +8933,8 @@
           </a:p>
         </p:txBody>
       </p:sp>
-      <mc:AlternateContent xmlns:mc="http://schemas.openxmlformats.org/markup-compatibility/2006">
-        <mc:Choice xmlns:a14="http://schemas.microsoft.com/office/drawing/2010/main" Requires="a14">
+      <mc:AlternateContent xmlns:mc="http://schemas.openxmlformats.org/markup-compatibility/2006" xmlns:a14="http://schemas.microsoft.com/office/drawing/2010/main">
+        <mc:Choice Requires="a14">
           <p:sp>
             <p:nvSpPr>
               <p:cNvPr id="19" name="TextBox 18">
@@ -9006,7 +9006,7 @@
             </p:txBody>
           </p:sp>
         </mc:Choice>
-        <mc:Fallback>
+        <mc:Fallback xmlns="">
           <p:sp>
             <p:nvSpPr>
               <p:cNvPr id="19" name="TextBox 18">
@@ -9051,8 +9051,8 @@
           </p:sp>
         </mc:Fallback>
       </mc:AlternateContent>
-      <mc:AlternateContent xmlns:mc="http://schemas.openxmlformats.org/markup-compatibility/2006">
-        <mc:Choice xmlns:a14="http://schemas.microsoft.com/office/drawing/2010/main" Requires="a14">
+      <mc:AlternateContent xmlns:mc="http://schemas.openxmlformats.org/markup-compatibility/2006" xmlns:a14="http://schemas.microsoft.com/office/drawing/2010/main">
+        <mc:Choice Requires="a14">
           <p:sp>
             <p:nvSpPr>
               <p:cNvPr id="20" name="TextBox 19">
@@ -9124,7 +9124,7 @@
             </p:txBody>
           </p:sp>
         </mc:Choice>
-        <mc:Fallback>
+        <mc:Fallback xmlns="">
           <p:sp>
             <p:nvSpPr>
               <p:cNvPr id="20" name="TextBox 19">
@@ -9213,8 +9213,8 @@
         </p:nvSpPr>
         <p:spPr>
           <a:xfrm>
-            <a:off x="3295650" y="-780554"/>
-            <a:ext cx="7251700" cy="8125301"/>
+            <a:off x="1134139" y="474088"/>
+            <a:ext cx="9781806" cy="5909310"/>
           </a:xfrm>
           <a:prstGeom prst="rect">
             <a:avLst/>

</xml_diff>